<commit_message>
feat: enforce resumable review formats and serial search checkpoints
</commit_message>
<xml_diff>
--- a/examples/case_study_corticosteroids_nma/editable_files/office_docs/Publication_Summary_16x9.pptx
+++ b/examples/case_study_corticosteroids_nma/editable_files/office_docs/Publication_Summary_16x9.pptx
@@ -3522,7 +3522,7 @@
               </a:defRPr>
             </a:pPr>
             <a:r>
-              <a:t>•  Corticosteroids significantly reduce 28-day mortality (OR 0.77, 95% CI [0.69, 0.87]).</a:t>
+              <a:t>•  QA fixture summary for 29 randomized controlled trials; not a production synthesis (pooled OR 0.77, 95% CI [0.69, 0.87]).</a:t>
             </a:r>
           </a:p>
           <a:p>
@@ -3554,7 +3554,7 @@
               </a:defRPr>
             </a:pPr>
             <a:r>
-              <a:t>•  Combination of hydrocortisone and fludrocortisone achieved highest SUCRA ranking.</a:t>
+              <a:t>•  Treatment ranking is not released from the bundled QA calculation.</a:t>
             </a:r>
           </a:p>
         </p:txBody>
@@ -3671,7 +3671,7 @@
               </a:defRPr>
             </a:pPr>
             <a:r>
-              <a:t>•  Supportive evidence for adjunctive corticosteroids in refractory septic shock.</a:t>
+              <a:t>•  QA fixture only; no clinical recommendation is released.</a:t>
             </a:r>
           </a:p>
           <a:p>
@@ -3687,7 +3687,7 @@
               </a:defRPr>
             </a:pPr>
             <a:r>
-              <a:t>•  Hydrocortisone + fludrocortisone regimen provides maximal mortality benefit.</a:t>
+              <a:t>•  No treatment ranking or clinical recommendation is released from this QA fixture.</a:t>
             </a:r>
           </a:p>
           <a:p>

</xml_diff>